<commit_message>
docs(ppt): nombres de integrantes y actualiza cuenta/VPC/ALB a sesion 26-06
Co-Authored-By: Claude Opus 4.8 <noreply@anthropic.com>
Claude-Session: https://claude.ai/code/session_01RGSUNUR7x2rUumoScYtZwM
</commit_message>
<xml_diff>
--- a/docs/EP3-Presentacion-Tienda-Perritos.pptx
+++ b/docs/EP3-Presentacion-Tienda-Perritos.pptx
@@ -4758,7 +4758,7 @@
                 </a:solidFill>
                 <a:latin typeface="Calibri"/>
               </a:rPr>
-              <a:t>Integrantes: [Integrante 1]  -  [Integrante 2]</a:t>
+              <a:t>Integrantes: Gabriel Molina  -  Jefferson Rojas</a:t>
             </a:r>
           </a:p>
           <a:p>
@@ -7792,7 +7792,7 @@
                 </a:solidFill>
                 <a:latin typeface="Calibri"/>
               </a:rPr>
-              <a:t>•  Region us-east-1  -  Cuenta 471112880379</a:t>
+              <a:t>•  Region us-east-1  -  Cuenta 166658674120</a:t>
             </a:r>
           </a:p>
           <a:p>
@@ -8195,7 +8195,7 @@
                 </a:solidFill>
                 <a:latin typeface="Calibri"/>
               </a:rPr>
-              <a:t>•  VPC vpc-0b7fae2d77b4d6487.</a:t>
+              <a:t>•  VPC vpc-00719b133c42a925b.</a:t>
             </a:r>
           </a:p>
           <a:p>
@@ -8510,7 +8510,7 @@
                 </a:solidFill>
                 <a:latin typeface="Calibri"/>
               </a:rPr>
-              <a:t>•  Acceso publico: http://tienda-alb-1107170895.us-east-1.elb.amazonaws.com</a:t>
+              <a:t>•  Acceso publico: http://tienda-alb-93590141.us-east-1.elb.amazonaws.com</a:t>
             </a:r>
           </a:p>
         </p:txBody>

</xml_diff>